<commit_message>
TrafficLens slide 16: program counts on the 1-minute clip (66/66 vehicles, 0/0 pedestrians, 14.7/14.9 FPS incl. saving); ground truth still being measured
Co-Authored-By: Claude Opus 5.5 <noreply@anthropic.com>
</commit_message>
<xml_diff>
--- a/ledger/static/ledger/projects/trafficlens/files/TrafficLens_slides.pptx
+++ b/ledger/static/ledger/projects/trafficlens/files/TrafficLens_slides.pptx
@@ -10156,7 +10156,7 @@
           <p:nvPr>
             <p:extLst>
               <p:ext uri="{D42A27DB-BD31-4B8C-83A1-F6EECF244321}">
-                <p14:modId xmlns:p14="http://schemas.microsoft.com/office/powerpoint/2010/main" val="3478407969"/>
+                <p14:modId xmlns:p14="http://schemas.microsoft.com/office/powerpoint/2010/main" val="2202878803"/>
               </p:ext>
             </p:extLst>
           </p:nvPr>
@@ -10639,7 +10639,7 @@
                         <a:buNone/>
                       </a:pPr>
                       <a:r>
-                        <a:rPr lang="ko-KR" altLang="en-US" sz="1600">
+                        <a:rPr lang="en-US" altLang="ko-KR" sz="1600">
                           <a:solidFill>
                             <a:srgbClr val="F4F3EE"/>
                           </a:solidFill>
@@ -10647,7 +10647,7 @@
                           <a:ea typeface="Arial" pitchFamily="34" charset="-122"/>
                           <a:cs typeface="Arial" pitchFamily="34" charset="-120"/>
                         </a:rPr>
-                        <a:t>측정 중</a:t>
+                        <a:t>66</a:t>
                       </a:r>
                       <a:endParaRPr lang="en-US" sz="1600" dirty="0">
                         <a:latin typeface="Arial" charset="0"/>
@@ -10707,7 +10707,7 @@
                         <a:buNone/>
                       </a:pPr>
                       <a:r>
-                        <a:rPr lang="ko-KR" altLang="en-US" sz="1600">
+                        <a:rPr lang="en-US" altLang="ko-KR" sz="1600">
                           <a:solidFill>
                             <a:srgbClr val="F4F3EE"/>
                           </a:solidFill>
@@ -10715,7 +10715,7 @@
                           <a:ea typeface="Arial" pitchFamily="34" charset="-122"/>
                           <a:cs typeface="Arial" pitchFamily="34" charset="-120"/>
                         </a:rPr>
-                        <a:t>측정 중</a:t>
+                        <a:t>66</a:t>
                       </a:r>
                       <a:endParaRPr lang="en-US" sz="1600" dirty="0">
                         <a:latin typeface="Arial" charset="0"/>
@@ -10918,7 +10918,7 @@
                         <a:buNone/>
                       </a:pPr>
                       <a:r>
-                        <a:rPr lang="ko-KR" altLang="en-US" sz="1600">
+                        <a:rPr lang="en-US" altLang="ko-KR" sz="1600">
                           <a:solidFill>
                             <a:srgbClr val="F4F3EE"/>
                           </a:solidFill>
@@ -10926,7 +10926,7 @@
                           <a:ea typeface="Arial" pitchFamily="34" charset="-122"/>
                           <a:cs typeface="Arial" pitchFamily="34" charset="-120"/>
                         </a:rPr>
-                        <a:t>측정 중</a:t>
+                        <a:t>0</a:t>
                       </a:r>
                       <a:endParaRPr lang="en-US" sz="1600" dirty="0">
                         <a:latin typeface="Arial" charset="0"/>
@@ -10986,7 +10986,7 @@
                         <a:buNone/>
                       </a:pPr>
                       <a:r>
-                        <a:rPr lang="ko-KR" altLang="en-US" sz="1600">
+                        <a:rPr lang="en-US" altLang="ko-KR" sz="1600">
                           <a:solidFill>
                             <a:srgbClr val="F4F3EE"/>
                           </a:solidFill>
@@ -10994,7 +10994,7 @@
                           <a:ea typeface="Arial" pitchFamily="34" charset="-122"/>
                           <a:cs typeface="Arial" pitchFamily="34" charset="-120"/>
                         </a:rPr>
-                        <a:t>측정 중</a:t>
+                        <a:t>0</a:t>
                       </a:r>
                       <a:endParaRPr lang="en-US" sz="1600" dirty="0">
                         <a:latin typeface="Arial" charset="0"/>
@@ -11619,7 +11619,7 @@
                         <a:buNone/>
                       </a:pPr>
                       <a:r>
-                        <a:rPr lang="en-US" sz="1600" dirty="0">
+                        <a:rPr lang="ko-KR" altLang="en-US" sz="1600">
                           <a:solidFill>
                             <a:srgbClr val="F4F3EE"/>
                           </a:solidFill>
@@ -11627,7 +11627,40 @@
                           <a:ea typeface="Arial" pitchFamily="34" charset="-122"/>
                           <a:cs typeface="Arial" pitchFamily="34" charset="-120"/>
                         </a:rPr>
-                        <a:t>평균 FPS</a:t>
+                        <a:t>평균 </a:t>
+                      </a:r>
+                      <a:r>
+                        <a:rPr lang="en-US" altLang="ko-KR" sz="1600">
+                          <a:solidFill>
+                            <a:srgbClr val="F4F3EE"/>
+                          </a:solidFill>
+                          <a:latin typeface="Arial" pitchFamily="34" charset="0"/>
+                          <a:ea typeface="Arial" pitchFamily="34" charset="-122"/>
+                          <a:cs typeface="Arial" pitchFamily="34" charset="-120"/>
+                        </a:rPr>
+                        <a:t>FPS (</a:t>
+                      </a:r>
+                      <a:r>
+                        <a:rPr lang="ko-KR" altLang="en-US" sz="1600">
+                          <a:solidFill>
+                            <a:srgbClr val="F4F3EE"/>
+                          </a:solidFill>
+                          <a:latin typeface="Arial" pitchFamily="34" charset="0"/>
+                          <a:ea typeface="Arial" pitchFamily="34" charset="-122"/>
+                          <a:cs typeface="Arial" pitchFamily="34" charset="-120"/>
+                        </a:rPr>
+                        <a:t>저장 포함</a:t>
+                      </a:r>
+                      <a:r>
+                        <a:rPr lang="en-US" altLang="ko-KR" sz="1600">
+                          <a:solidFill>
+                            <a:srgbClr val="F4F3EE"/>
+                          </a:solidFill>
+                          <a:latin typeface="Arial" pitchFamily="34" charset="0"/>
+                          <a:ea typeface="Arial" pitchFamily="34" charset="-122"/>
+                          <a:cs typeface="Arial" pitchFamily="34" charset="-120"/>
+                        </a:rPr>
+                        <a:t>)</a:t>
                       </a:r>
                       <a:endParaRPr lang="en-US" sz="1600" dirty="0">
                         <a:latin typeface="Arial" charset="0"/>
@@ -11755,7 +11788,7 @@
                         <a:buNone/>
                       </a:pPr>
                       <a:r>
-                        <a:rPr lang="ko-KR" altLang="en-US" sz="1600">
+                        <a:rPr lang="en-US" altLang="ko-KR" sz="1600">
                           <a:solidFill>
                             <a:srgbClr val="F4F3EE"/>
                           </a:solidFill>
@@ -11763,7 +11796,7 @@
                           <a:ea typeface="Arial" pitchFamily="34" charset="-122"/>
                           <a:cs typeface="Arial" pitchFamily="34" charset="-120"/>
                         </a:rPr>
-                        <a:t>측정 중</a:t>
+                        <a:t>14.7</a:t>
                       </a:r>
                       <a:endParaRPr lang="en-US" sz="1600" dirty="0">
                         <a:latin typeface="Arial" charset="0"/>
@@ -11823,7 +11856,7 @@
                         <a:buNone/>
                       </a:pPr>
                       <a:r>
-                        <a:rPr lang="ko-KR" altLang="en-US" sz="1600">
+                        <a:rPr lang="en-US" altLang="ko-KR" sz="1600">
                           <a:solidFill>
                             <a:srgbClr val="F4F3EE"/>
                           </a:solidFill>
@@ -11831,7 +11864,7 @@
                           <a:ea typeface="Arial" pitchFamily="34" charset="-122"/>
                           <a:cs typeface="Arial" pitchFamily="34" charset="-120"/>
                         </a:rPr>
-                        <a:t>측정 중</a:t>
+                        <a:t>14.9</a:t>
                       </a:r>
                       <a:endParaRPr lang="en-US" sz="1600" dirty="0">
                         <a:latin typeface="Arial" charset="0"/>

</xml_diff>

<commit_message>
TrafficLens slide 16: drop the error rows until ground truth is counted
Co-Authored-By: Claude Opus 5.5 <noreply@anthropic.com>
</commit_message>
<xml_diff>
--- a/ledger/static/ledger/projects/trafficlens/files/TrafficLens_slides.pptx
+++ b/ledger/static/ledger/projects/trafficlens/files/TrafficLens_slides.pptx
@@ -10156,13 +10156,13 @@
           <p:nvPr>
             <p:extLst>
               <p:ext uri="{D42A27DB-BD31-4B8C-83A1-F6EECF244321}">
-                <p14:modId xmlns:p14="http://schemas.microsoft.com/office/powerpoint/2010/main" val="2202878803"/>
+                <p14:modId xmlns:p14="http://schemas.microsoft.com/office/powerpoint/2010/main" val="3223742520"/>
               </p:ext>
             </p:extLst>
           </p:nvPr>
         </p:nvGraphicFramePr>
         <p:xfrm>
-          <a:off x="4787900" y="2588716"/>
+          <a:off x="4787900" y="3027957"/>
           <a:ext cx="6591300" cy="2635448"/>
         </p:xfrm>
         <a:graphic>
@@ -11045,564 +11045,6 @@
                 <a:extLst>
                   <a:ext uri="{0D108BD9-81ED-4DB2-BD59-A6C34878D82A}">
                     <a16:rowId xmlns:a16="http://schemas.microsoft.com/office/drawing/2014/main" val="10002"/>
-                  </a:ext>
-                </a:extLst>
-              </a:tr>
-              <a:tr h="439241">
-                <a:tc>
-                  <a:txBody>
-                    <a:bodyPr/>
-                    <a:lstStyle/>
-                    <a:p>
-                      <a:pPr marL="0" indent="0">
-                        <a:lnSpc>
-                          <a:spcPts val="2240"/>
-                        </a:lnSpc>
-                        <a:buNone/>
-                      </a:pPr>
-                      <a:r>
-                        <a:rPr lang="en-US" sz="1600" dirty="0">
-                          <a:solidFill>
-                            <a:srgbClr val="F4F3EE"/>
-                          </a:solidFill>
-                          <a:latin typeface="Arial" pitchFamily="34" charset="0"/>
-                          <a:ea typeface="Arial" pitchFamily="34" charset="-122"/>
-                          <a:cs typeface="Arial" pitchFamily="34" charset="-120"/>
-                        </a:rPr>
-                        <a:t>차량 오차</a:t>
-                      </a:r>
-                      <a:endParaRPr lang="en-US" sz="1600" dirty="0">
-                        <a:latin typeface="Arial" charset="0"/>
-                        <a:ea typeface="Arial" charset="0"/>
-                        <a:cs typeface="Arial" charset="0"/>
-                      </a:endParaRPr>
-                    </a:p>
-                  </a:txBody>
-                  <a:tcPr marL="71120" marR="71120" marT="71120" marB="71120">
-                    <a:lnL w="12700" cap="flat" cmpd="sng" algn="ctr">
-                      <a:solidFill>
-                        <a:srgbClr val="474A4E"/>
-                      </a:solidFill>
-                      <a:prstDash val="solid"/>
-                      <a:round/>
-                      <a:headEnd type="none" w="med" len="med"/>
-                      <a:tailEnd type="none" w="med" len="med"/>
-                    </a:lnL>
-                    <a:lnR w="12700" cap="flat" cmpd="sng" algn="ctr">
-                      <a:solidFill>
-                        <a:srgbClr val="474A4E"/>
-                      </a:solidFill>
-                      <a:prstDash val="solid"/>
-                      <a:round/>
-                      <a:headEnd type="none" w="med" len="med"/>
-                      <a:tailEnd type="none" w="med" len="med"/>
-                    </a:lnR>
-                    <a:lnT w="12700" cap="flat" cmpd="sng" algn="ctr">
-                      <a:solidFill>
-                        <a:srgbClr val="474A4E"/>
-                      </a:solidFill>
-                      <a:prstDash val="solid"/>
-                      <a:round/>
-                      <a:headEnd type="none" w="med" len="med"/>
-                      <a:tailEnd type="none" w="med" len="med"/>
-                    </a:lnT>
-                    <a:lnB w="12700" cap="flat" cmpd="sng" algn="ctr">
-                      <a:solidFill>
-                        <a:srgbClr val="474A4E"/>
-                      </a:solidFill>
-                      <a:prstDash val="solid"/>
-                      <a:round/>
-                      <a:headEnd type="none" w="med" len="med"/>
-                      <a:tailEnd type="none" w="med" len="med"/>
-                    </a:lnB>
-                  </a:tcPr>
-                </a:tc>
-                <a:tc>
-                  <a:txBody>
-                    <a:bodyPr/>
-                    <a:lstStyle/>
-                    <a:p>
-                      <a:pPr marL="0" indent="0" algn="r">
-                        <a:lnSpc>
-                          <a:spcPts val="2240"/>
-                        </a:lnSpc>
-                        <a:buNone/>
-                      </a:pPr>
-                      <a:r>
-                        <a:rPr lang="en-US" sz="1600" dirty="0">
-                          <a:solidFill>
-                            <a:srgbClr val="F4F3EE"/>
-                          </a:solidFill>
-                          <a:latin typeface="Arial" pitchFamily="34" charset="0"/>
-                          <a:ea typeface="Arial" pitchFamily="34" charset="-122"/>
-                          <a:cs typeface="Arial" pitchFamily="34" charset="-120"/>
-                        </a:rPr>
-                        <a:t>—</a:t>
-                      </a:r>
-                      <a:endParaRPr lang="en-US" sz="1600" dirty="0">
-                        <a:latin typeface="Arial" charset="0"/>
-                        <a:ea typeface="Arial" charset="0"/>
-                        <a:cs typeface="Arial" charset="0"/>
-                      </a:endParaRPr>
-                    </a:p>
-                  </a:txBody>
-                  <a:tcPr marL="71120" marR="71120" marT="71120" marB="71120">
-                    <a:lnL w="12700" cap="flat" cmpd="sng" algn="ctr">
-                      <a:solidFill>
-                        <a:srgbClr val="474A4E"/>
-                      </a:solidFill>
-                      <a:prstDash val="solid"/>
-                      <a:round/>
-                      <a:headEnd type="none" w="med" len="med"/>
-                      <a:tailEnd type="none" w="med" len="med"/>
-                    </a:lnL>
-                    <a:lnR w="12700" cap="flat" cmpd="sng" algn="ctr">
-                      <a:solidFill>
-                        <a:srgbClr val="474A4E"/>
-                      </a:solidFill>
-                      <a:prstDash val="solid"/>
-                      <a:round/>
-                      <a:headEnd type="none" w="med" len="med"/>
-                      <a:tailEnd type="none" w="med" len="med"/>
-                    </a:lnR>
-                    <a:lnT w="12700" cap="flat" cmpd="sng" algn="ctr">
-                      <a:solidFill>
-                        <a:srgbClr val="474A4E"/>
-                      </a:solidFill>
-                      <a:prstDash val="solid"/>
-                      <a:round/>
-                      <a:headEnd type="none" w="med" len="med"/>
-                      <a:tailEnd type="none" w="med" len="med"/>
-                    </a:lnT>
-                    <a:lnB w="12700" cap="flat" cmpd="sng" algn="ctr">
-                      <a:solidFill>
-                        <a:srgbClr val="474A4E"/>
-                      </a:solidFill>
-                      <a:prstDash val="solid"/>
-                      <a:round/>
-                      <a:headEnd type="none" w="med" len="med"/>
-                      <a:tailEnd type="none" w="med" len="med"/>
-                    </a:lnB>
-                  </a:tcPr>
-                </a:tc>
-                <a:tc>
-                  <a:txBody>
-                    <a:bodyPr/>
-                    <a:lstStyle/>
-                    <a:p>
-                      <a:pPr marL="0" indent="0" algn="r">
-                        <a:lnSpc>
-                          <a:spcPts val="2240"/>
-                        </a:lnSpc>
-                        <a:buNone/>
-                      </a:pPr>
-                      <a:r>
-                        <a:rPr lang="ko-KR" altLang="en-US" sz="1600">
-                          <a:solidFill>
-                            <a:srgbClr val="F4F3EE"/>
-                          </a:solidFill>
-                          <a:latin typeface="Arial" pitchFamily="34" charset="0"/>
-                          <a:ea typeface="Arial" pitchFamily="34" charset="-122"/>
-                          <a:cs typeface="Arial" pitchFamily="34" charset="-120"/>
-                        </a:rPr>
-                        <a:t>측정 중</a:t>
-                      </a:r>
-                      <a:endParaRPr lang="en-US" sz="1600" dirty="0">
-                        <a:latin typeface="Arial" charset="0"/>
-                        <a:ea typeface="Arial" charset="0"/>
-                        <a:cs typeface="Arial" charset="0"/>
-                      </a:endParaRPr>
-                    </a:p>
-                  </a:txBody>
-                  <a:tcPr marL="71120" marR="71120" marT="71120" marB="71120">
-                    <a:lnL w="12700" cap="flat" cmpd="sng" algn="ctr">
-                      <a:solidFill>
-                        <a:srgbClr val="474A4E"/>
-                      </a:solidFill>
-                      <a:prstDash val="solid"/>
-                      <a:round/>
-                      <a:headEnd type="none" w="med" len="med"/>
-                      <a:tailEnd type="none" w="med" len="med"/>
-                    </a:lnL>
-                    <a:lnR w="12700" cap="flat" cmpd="sng" algn="ctr">
-                      <a:solidFill>
-                        <a:srgbClr val="474A4E"/>
-                      </a:solidFill>
-                      <a:prstDash val="solid"/>
-                      <a:round/>
-                      <a:headEnd type="none" w="med" len="med"/>
-                      <a:tailEnd type="none" w="med" len="med"/>
-                    </a:lnR>
-                    <a:lnT w="12700" cap="flat" cmpd="sng" algn="ctr">
-                      <a:solidFill>
-                        <a:srgbClr val="474A4E"/>
-                      </a:solidFill>
-                      <a:prstDash val="solid"/>
-                      <a:round/>
-                      <a:headEnd type="none" w="med" len="med"/>
-                      <a:tailEnd type="none" w="med" len="med"/>
-                    </a:lnT>
-                    <a:lnB w="12700" cap="flat" cmpd="sng" algn="ctr">
-                      <a:solidFill>
-                        <a:srgbClr val="474A4E"/>
-                      </a:solidFill>
-                      <a:prstDash val="solid"/>
-                      <a:round/>
-                      <a:headEnd type="none" w="med" len="med"/>
-                      <a:tailEnd type="none" w="med" len="med"/>
-                    </a:lnB>
-                  </a:tcPr>
-                </a:tc>
-                <a:tc>
-                  <a:txBody>
-                    <a:bodyPr/>
-                    <a:lstStyle/>
-                    <a:p>
-                      <a:pPr marL="0" indent="0" algn="r">
-                        <a:lnSpc>
-                          <a:spcPts val="2240"/>
-                        </a:lnSpc>
-                        <a:buNone/>
-                      </a:pPr>
-                      <a:r>
-                        <a:rPr lang="ko-KR" altLang="en-US" sz="1600">
-                          <a:solidFill>
-                            <a:srgbClr val="F4F3EE"/>
-                          </a:solidFill>
-                          <a:latin typeface="Arial" pitchFamily="34" charset="0"/>
-                          <a:ea typeface="Arial" pitchFamily="34" charset="-122"/>
-                          <a:cs typeface="Arial" pitchFamily="34" charset="-120"/>
-                        </a:rPr>
-                        <a:t>측정 중</a:t>
-                      </a:r>
-                      <a:endParaRPr lang="en-US" sz="1600" dirty="0">
-                        <a:latin typeface="Arial" charset="0"/>
-                        <a:ea typeface="Arial" charset="0"/>
-                        <a:cs typeface="Arial" charset="0"/>
-                      </a:endParaRPr>
-                    </a:p>
-                  </a:txBody>
-                  <a:tcPr marL="71120" marR="71120" marT="71120" marB="71120">
-                    <a:lnL w="12700" cap="flat" cmpd="sng" algn="ctr">
-                      <a:solidFill>
-                        <a:srgbClr val="474A4E"/>
-                      </a:solidFill>
-                      <a:prstDash val="solid"/>
-                      <a:round/>
-                      <a:headEnd type="none" w="med" len="med"/>
-                      <a:tailEnd type="none" w="med" len="med"/>
-                    </a:lnL>
-                    <a:lnR w="12700" cap="flat" cmpd="sng" algn="ctr">
-                      <a:solidFill>
-                        <a:srgbClr val="474A4E"/>
-                      </a:solidFill>
-                      <a:prstDash val="solid"/>
-                      <a:round/>
-                      <a:headEnd type="none" w="med" len="med"/>
-                      <a:tailEnd type="none" w="med" len="med"/>
-                    </a:lnR>
-                    <a:lnT w="12700" cap="flat" cmpd="sng" algn="ctr">
-                      <a:solidFill>
-                        <a:srgbClr val="474A4E"/>
-                      </a:solidFill>
-                      <a:prstDash val="solid"/>
-                      <a:round/>
-                      <a:headEnd type="none" w="med" len="med"/>
-                      <a:tailEnd type="none" w="med" len="med"/>
-                    </a:lnT>
-                    <a:lnB w="12700" cap="flat" cmpd="sng" algn="ctr">
-                      <a:solidFill>
-                        <a:srgbClr val="474A4E"/>
-                      </a:solidFill>
-                      <a:prstDash val="solid"/>
-                      <a:round/>
-                      <a:headEnd type="none" w="med" len="med"/>
-                      <a:tailEnd type="none" w="med" len="med"/>
-                    </a:lnB>
-                  </a:tcPr>
-                </a:tc>
-                <a:extLst>
-                  <a:ext uri="{0D108BD9-81ED-4DB2-BD59-A6C34878D82A}">
-                    <a16:rowId xmlns:a16="http://schemas.microsoft.com/office/drawing/2014/main" val="10003"/>
-                  </a:ext>
-                </a:extLst>
-              </a:tr>
-              <a:tr h="439241">
-                <a:tc>
-                  <a:txBody>
-                    <a:bodyPr/>
-                    <a:lstStyle/>
-                    <a:p>
-                      <a:pPr marL="0" indent="0">
-                        <a:lnSpc>
-                          <a:spcPts val="2240"/>
-                        </a:lnSpc>
-                        <a:buNone/>
-                      </a:pPr>
-                      <a:r>
-                        <a:rPr lang="en-US" sz="1600" dirty="0">
-                          <a:solidFill>
-                            <a:srgbClr val="F4F3EE"/>
-                          </a:solidFill>
-                          <a:latin typeface="Arial" pitchFamily="34" charset="0"/>
-                          <a:ea typeface="Arial" pitchFamily="34" charset="-122"/>
-                          <a:cs typeface="Arial" pitchFamily="34" charset="-120"/>
-                        </a:rPr>
-                        <a:t>보행자 오차</a:t>
-                      </a:r>
-                      <a:endParaRPr lang="en-US" sz="1600" dirty="0">
-                        <a:latin typeface="Arial" charset="0"/>
-                        <a:ea typeface="Arial" charset="0"/>
-                        <a:cs typeface="Arial" charset="0"/>
-                      </a:endParaRPr>
-                    </a:p>
-                  </a:txBody>
-                  <a:tcPr marL="71120" marR="71120" marT="71120" marB="71120">
-                    <a:lnL w="12700" cap="flat" cmpd="sng" algn="ctr">
-                      <a:solidFill>
-                        <a:srgbClr val="474A4E"/>
-                      </a:solidFill>
-                      <a:prstDash val="solid"/>
-                      <a:round/>
-                      <a:headEnd type="none" w="med" len="med"/>
-                      <a:tailEnd type="none" w="med" len="med"/>
-                    </a:lnL>
-                    <a:lnR w="12700" cap="flat" cmpd="sng" algn="ctr">
-                      <a:solidFill>
-                        <a:srgbClr val="474A4E"/>
-                      </a:solidFill>
-                      <a:prstDash val="solid"/>
-                      <a:round/>
-                      <a:headEnd type="none" w="med" len="med"/>
-                      <a:tailEnd type="none" w="med" len="med"/>
-                    </a:lnR>
-                    <a:lnT w="12700" cap="flat" cmpd="sng" algn="ctr">
-                      <a:solidFill>
-                        <a:srgbClr val="474A4E"/>
-                      </a:solidFill>
-                      <a:prstDash val="solid"/>
-                      <a:round/>
-                      <a:headEnd type="none" w="med" len="med"/>
-                      <a:tailEnd type="none" w="med" len="med"/>
-                    </a:lnT>
-                    <a:lnB w="12700" cap="flat" cmpd="sng" algn="ctr">
-                      <a:solidFill>
-                        <a:srgbClr val="474A4E"/>
-                      </a:solidFill>
-                      <a:prstDash val="solid"/>
-                      <a:round/>
-                      <a:headEnd type="none" w="med" len="med"/>
-                      <a:tailEnd type="none" w="med" len="med"/>
-                    </a:lnB>
-                  </a:tcPr>
-                </a:tc>
-                <a:tc>
-                  <a:txBody>
-                    <a:bodyPr/>
-                    <a:lstStyle/>
-                    <a:p>
-                      <a:pPr marL="0" indent="0" algn="r">
-                        <a:lnSpc>
-                          <a:spcPts val="2240"/>
-                        </a:lnSpc>
-                        <a:buNone/>
-                      </a:pPr>
-                      <a:r>
-                        <a:rPr lang="en-US" sz="1600" dirty="0">
-                          <a:solidFill>
-                            <a:srgbClr val="F4F3EE"/>
-                          </a:solidFill>
-                          <a:latin typeface="Arial" pitchFamily="34" charset="0"/>
-                          <a:ea typeface="Arial" pitchFamily="34" charset="-122"/>
-                          <a:cs typeface="Arial" pitchFamily="34" charset="-120"/>
-                        </a:rPr>
-                        <a:t>—</a:t>
-                      </a:r>
-                      <a:endParaRPr lang="en-US" sz="1600" dirty="0">
-                        <a:latin typeface="Arial" charset="0"/>
-                        <a:ea typeface="Arial" charset="0"/>
-                        <a:cs typeface="Arial" charset="0"/>
-                      </a:endParaRPr>
-                    </a:p>
-                  </a:txBody>
-                  <a:tcPr marL="71120" marR="71120" marT="71120" marB="71120">
-                    <a:lnL w="12700" cap="flat" cmpd="sng" algn="ctr">
-                      <a:solidFill>
-                        <a:srgbClr val="474A4E"/>
-                      </a:solidFill>
-                      <a:prstDash val="solid"/>
-                      <a:round/>
-                      <a:headEnd type="none" w="med" len="med"/>
-                      <a:tailEnd type="none" w="med" len="med"/>
-                    </a:lnL>
-                    <a:lnR w="12700" cap="flat" cmpd="sng" algn="ctr">
-                      <a:solidFill>
-                        <a:srgbClr val="474A4E"/>
-                      </a:solidFill>
-                      <a:prstDash val="solid"/>
-                      <a:round/>
-                      <a:headEnd type="none" w="med" len="med"/>
-                      <a:tailEnd type="none" w="med" len="med"/>
-                    </a:lnR>
-                    <a:lnT w="12700" cap="flat" cmpd="sng" algn="ctr">
-                      <a:solidFill>
-                        <a:srgbClr val="474A4E"/>
-                      </a:solidFill>
-                      <a:prstDash val="solid"/>
-                      <a:round/>
-                      <a:headEnd type="none" w="med" len="med"/>
-                      <a:tailEnd type="none" w="med" len="med"/>
-                    </a:lnT>
-                    <a:lnB w="12700" cap="flat" cmpd="sng" algn="ctr">
-                      <a:solidFill>
-                        <a:srgbClr val="474A4E"/>
-                      </a:solidFill>
-                      <a:prstDash val="solid"/>
-                      <a:round/>
-                      <a:headEnd type="none" w="med" len="med"/>
-                      <a:tailEnd type="none" w="med" len="med"/>
-                    </a:lnB>
-                  </a:tcPr>
-                </a:tc>
-                <a:tc>
-                  <a:txBody>
-                    <a:bodyPr/>
-                    <a:lstStyle/>
-                    <a:p>
-                      <a:pPr marL="0" indent="0" algn="r">
-                        <a:lnSpc>
-                          <a:spcPts val="2240"/>
-                        </a:lnSpc>
-                        <a:buNone/>
-                      </a:pPr>
-                      <a:r>
-                        <a:rPr lang="ko-KR" altLang="en-US" sz="1600">
-                          <a:solidFill>
-                            <a:srgbClr val="F4F3EE"/>
-                          </a:solidFill>
-                          <a:latin typeface="Arial" pitchFamily="34" charset="0"/>
-                          <a:ea typeface="Arial" pitchFamily="34" charset="-122"/>
-                          <a:cs typeface="Arial" pitchFamily="34" charset="-120"/>
-                        </a:rPr>
-                        <a:t>측정 중</a:t>
-                      </a:r>
-                      <a:endParaRPr lang="en-US" sz="1600" dirty="0">
-                        <a:latin typeface="Arial" charset="0"/>
-                        <a:ea typeface="Arial" charset="0"/>
-                        <a:cs typeface="Arial" charset="0"/>
-                      </a:endParaRPr>
-                    </a:p>
-                  </a:txBody>
-                  <a:tcPr marL="71120" marR="71120" marT="71120" marB="71120">
-                    <a:lnL w="12700" cap="flat" cmpd="sng" algn="ctr">
-                      <a:solidFill>
-                        <a:srgbClr val="474A4E"/>
-                      </a:solidFill>
-                      <a:prstDash val="solid"/>
-                      <a:round/>
-                      <a:headEnd type="none" w="med" len="med"/>
-                      <a:tailEnd type="none" w="med" len="med"/>
-                    </a:lnL>
-                    <a:lnR w="12700" cap="flat" cmpd="sng" algn="ctr">
-                      <a:solidFill>
-                        <a:srgbClr val="474A4E"/>
-                      </a:solidFill>
-                      <a:prstDash val="solid"/>
-                      <a:round/>
-                      <a:headEnd type="none" w="med" len="med"/>
-                      <a:tailEnd type="none" w="med" len="med"/>
-                    </a:lnR>
-                    <a:lnT w="12700" cap="flat" cmpd="sng" algn="ctr">
-                      <a:solidFill>
-                        <a:srgbClr val="474A4E"/>
-                      </a:solidFill>
-                      <a:prstDash val="solid"/>
-                      <a:round/>
-                      <a:headEnd type="none" w="med" len="med"/>
-                      <a:tailEnd type="none" w="med" len="med"/>
-                    </a:lnT>
-                    <a:lnB w="12700" cap="flat" cmpd="sng" algn="ctr">
-                      <a:solidFill>
-                        <a:srgbClr val="474A4E"/>
-                      </a:solidFill>
-                      <a:prstDash val="solid"/>
-                      <a:round/>
-                      <a:headEnd type="none" w="med" len="med"/>
-                      <a:tailEnd type="none" w="med" len="med"/>
-                    </a:lnB>
-                  </a:tcPr>
-                </a:tc>
-                <a:tc>
-                  <a:txBody>
-                    <a:bodyPr/>
-                    <a:lstStyle/>
-                    <a:p>
-                      <a:pPr marL="0" indent="0" algn="r">
-                        <a:lnSpc>
-                          <a:spcPts val="2240"/>
-                        </a:lnSpc>
-                        <a:buNone/>
-                      </a:pPr>
-                      <a:r>
-                        <a:rPr lang="ko-KR" altLang="en-US" sz="1600">
-                          <a:solidFill>
-                            <a:srgbClr val="F4F3EE"/>
-                          </a:solidFill>
-                          <a:latin typeface="Arial" pitchFamily="34" charset="0"/>
-                          <a:ea typeface="Arial" pitchFamily="34" charset="-122"/>
-                          <a:cs typeface="Arial" pitchFamily="34" charset="-120"/>
-                        </a:rPr>
-                        <a:t>측정 중</a:t>
-                      </a:r>
-                      <a:endParaRPr lang="en-US" sz="1600" dirty="0">
-                        <a:latin typeface="Arial" charset="0"/>
-                        <a:ea typeface="Arial" charset="0"/>
-                        <a:cs typeface="Arial" charset="0"/>
-                      </a:endParaRPr>
-                    </a:p>
-                  </a:txBody>
-                  <a:tcPr marL="71120" marR="71120" marT="71120" marB="71120">
-                    <a:lnL w="12700" cap="flat" cmpd="sng" algn="ctr">
-                      <a:solidFill>
-                        <a:srgbClr val="474A4E"/>
-                      </a:solidFill>
-                      <a:prstDash val="solid"/>
-                      <a:round/>
-                      <a:headEnd type="none" w="med" len="med"/>
-                      <a:tailEnd type="none" w="med" len="med"/>
-                    </a:lnL>
-                    <a:lnR w="12700" cap="flat" cmpd="sng" algn="ctr">
-                      <a:solidFill>
-                        <a:srgbClr val="474A4E"/>
-                      </a:solidFill>
-                      <a:prstDash val="solid"/>
-                      <a:round/>
-                      <a:headEnd type="none" w="med" len="med"/>
-                      <a:tailEnd type="none" w="med" len="med"/>
-                    </a:lnR>
-                    <a:lnT w="12700" cap="flat" cmpd="sng" algn="ctr">
-                      <a:solidFill>
-                        <a:srgbClr val="474A4E"/>
-                      </a:solidFill>
-                      <a:prstDash val="solid"/>
-                      <a:round/>
-                      <a:headEnd type="none" w="med" len="med"/>
-                      <a:tailEnd type="none" w="med" len="med"/>
-                    </a:lnT>
-                    <a:lnB w="12700" cap="flat" cmpd="sng" algn="ctr">
-                      <a:solidFill>
-                        <a:srgbClr val="474A4E"/>
-                      </a:solidFill>
-                      <a:prstDash val="solid"/>
-                      <a:round/>
-                      <a:headEnd type="none" w="med" len="med"/>
-                      <a:tailEnd type="none" w="med" len="med"/>
-                    </a:lnB>
-                  </a:tcPr>
-                </a:tc>
-                <a:extLst>
-                  <a:ext uri="{0D108BD9-81ED-4DB2-BD59-A6C34878D82A}">
-                    <a16:rowId xmlns:a16="http://schemas.microsoft.com/office/drawing/2014/main" val="10004"/>
                   </a:ext>
                 </a:extLst>
               </a:tr>

</xml_diff>

<commit_message>
TrafficLens slide 16 title: 1분 구간 측정 결과
Co-Authored-By: Claude Opus 5.5 <noreply@anthropic.com>
</commit_message>
<xml_diff>
--- a/ledger/static/ledger/projects/trafficlens/files/TrafficLens_slides.pptx
+++ b/ledger/static/ledger/projects/trafficlens/files/TrafficLens_slides.pptx
@@ -9926,7 +9926,7 @@
               <a:buNone/>
             </a:pPr>
             <a:r>
-              <a:rPr lang="en-US" sz="3600" b="1" i="0" dirty="0">
+              <a:rPr lang="en-US" altLang="ko-KR" sz="3600" b="1" i="0">
                 <a:solidFill>
                   <a:srgbClr val="F4F3EE"/>
                 </a:solidFill>
@@ -9934,7 +9934,18 @@
                 <a:ea typeface="Arial" pitchFamily="34" charset="-122"/>
                 <a:cs typeface="Arial" pitchFamily="34" charset="-120"/>
               </a:rPr>
-              <a:t>직접 센 정답과 비교했습니다</a:t>
+              <a:t>1</a:t>
+            </a:r>
+            <a:r>
+              <a:rPr lang="ko-KR" altLang="en-US" sz="3600" b="1" i="0">
+                <a:solidFill>
+                  <a:srgbClr val="F4F3EE"/>
+                </a:solidFill>
+                <a:latin typeface="Arial" pitchFamily="34" charset="0"/>
+                <a:ea typeface="Arial" pitchFamily="34" charset="-122"/>
+                <a:cs typeface="Arial" pitchFamily="34" charset="-120"/>
+              </a:rPr>
+              <a:t>분 구간 측정 결과</a:t>
             </a:r>
             <a:endParaRPr lang="en-US" sz="3600" dirty="0"/>
           </a:p>

</xml_diff>

<commit_message>
TrafficLens slide 16: left block shows 66 vehicles instead of 'measuring'
Co-Authored-By: Claude Opus 5.5 <noreply@anthropic.com>
</commit_message>
<xml_diff>
--- a/ledger/static/ledger/projects/trafficlens/files/TrafficLens_slides.pptx
+++ b/ledger/static/ledger/projects/trafficlens/files/TrafficLens_slides.pptx
@@ -9981,7 +9981,7 @@
               <a:buNone/>
             </a:pPr>
             <a:r>
-              <a:rPr lang="en-US" sz="1200" b="1" dirty="0">
+              <a:rPr lang="ko-KR" altLang="en-US" sz="1200" b="1">
                 <a:solidFill>
                   <a:srgbClr val="C3C9D3"/>
                 </a:solidFill>
@@ -9989,7 +9989,29 @@
                 <a:ea typeface="Arial" pitchFamily="34" charset="-122"/>
                 <a:cs typeface="Arial" pitchFamily="34" charset="-120"/>
               </a:rPr>
-              <a:t>기준선 통과 수 오차</a:t>
+              <a:t>기준선 통과 차량 </a:t>
+            </a:r>
+            <a:r>
+              <a:rPr lang="en-US" altLang="ko-KR" sz="1200" b="1">
+                <a:solidFill>
+                  <a:srgbClr val="C3C9D3"/>
+                </a:solidFill>
+                <a:latin typeface="Arial" pitchFamily="34" charset="0"/>
+                <a:ea typeface="Arial" pitchFamily="34" charset="-122"/>
+                <a:cs typeface="Arial" pitchFamily="34" charset="-120"/>
+              </a:rPr>
+              <a:t>· 1</a:t>
+            </a:r>
+            <a:r>
+              <a:rPr lang="ko-KR" altLang="en-US" sz="1200" b="1">
+                <a:solidFill>
+                  <a:srgbClr val="C3C9D3"/>
+                </a:solidFill>
+                <a:latin typeface="Arial" pitchFamily="34" charset="0"/>
+                <a:ea typeface="Arial" pitchFamily="34" charset="-122"/>
+                <a:cs typeface="Arial" pitchFamily="34" charset="-120"/>
+              </a:rPr>
+              <a:t>분 구간</a:t>
             </a:r>
             <a:endParaRPr lang="en-US" sz="1200" dirty="0"/>
           </a:p>
@@ -10025,6 +10047,17 @@
               <a:buNone/>
             </a:pPr>
             <a:r>
+              <a:rPr lang="en-US" altLang="ko-KR" sz="3600" b="1">
+                <a:solidFill>
+                  <a:srgbClr val="F2C230"/>
+                </a:solidFill>
+                <a:latin typeface="Arial" pitchFamily="34" charset="0"/>
+                <a:ea typeface="Arial" pitchFamily="34" charset="-122"/>
+                <a:cs typeface="Arial" pitchFamily="34" charset="-120"/>
+              </a:rPr>
+              <a:t>66</a:t>
+            </a:r>
+            <a:r>
               <a:rPr lang="ko-KR" altLang="en-US" sz="3600" b="1">
                 <a:solidFill>
                   <a:srgbClr val="F2C230"/>
@@ -10033,7 +10066,7 @@
                 <a:ea typeface="Arial" pitchFamily="34" charset="-122"/>
                 <a:cs typeface="Arial" pitchFamily="34" charset="-120"/>
               </a:rPr>
-              <a:t>측정 중</a:t>
+              <a:t>대</a:t>
             </a:r>
             <a:endParaRPr lang="en-US" sz="3600" dirty="0"/>
           </a:p>
@@ -10069,7 +10102,7 @@
               <a:buNone/>
             </a:pPr>
             <a:r>
-              <a:rPr lang="en-US" sz="1200" dirty="0">
+              <a:rPr lang="ko-KR" altLang="en-US" sz="1200">
                 <a:solidFill>
                   <a:srgbClr val="C3C9D3"/>
                 </a:solidFill>
@@ -10077,7 +10110,7 @@
                 <a:ea typeface="Arial" pitchFamily="34" charset="-122"/>
                 <a:cs typeface="Arial" pitchFamily="34" charset="-120"/>
               </a:rPr>
-              <a:t>기본 버전 → 개선 버전</a:t>
+              <a:t>기본 버전과 개선 버전이 같은 수</a:t>
             </a:r>
             <a:endParaRPr lang="en-US" sz="1200" dirty="0"/>
           </a:p>
@@ -10089,7 +10122,7 @@
               <a:buNone/>
             </a:pPr>
             <a:r>
-              <a:rPr lang="en-US" sz="1200" dirty="0">
+              <a:rPr lang="ko-KR" altLang="en-US" sz="1200">
                 <a:solidFill>
                   <a:srgbClr val="C3C9D3"/>
                 </a:solidFill>
@@ -10097,62 +10130,7 @@
                 <a:ea typeface="Arial" pitchFamily="34" charset="-122"/>
                 <a:cs typeface="Arial" pitchFamily="34" charset="-120"/>
               </a:rPr>
-              <a:t>테스트 </a:t>
-            </a:r>
-            <a:r>
-              <a:rPr lang="en-US" sz="1200">
-                <a:solidFill>
-                  <a:srgbClr val="C3C9D3"/>
-                </a:solidFill>
-                <a:latin typeface="Arial" pitchFamily="34" charset="0"/>
-                <a:ea typeface="Arial" pitchFamily="34" charset="-122"/>
-                <a:cs typeface="Arial" pitchFamily="34" charset="-120"/>
-              </a:rPr>
-              <a:t>영상 </a:t>
-            </a:r>
-            <a:r>
-              <a:rPr lang="en-US" altLang="ko-KR" sz="1200">
-                <a:solidFill>
-                  <a:srgbClr val="C3C9D3"/>
-                </a:solidFill>
-                <a:latin typeface="Arial" pitchFamily="34" charset="0"/>
-                <a:ea typeface="Arial" pitchFamily="34" charset="-122"/>
-                <a:cs typeface="Arial" pitchFamily="34" charset="-120"/>
-              </a:rPr>
-              <a:t>1</a:t>
-            </a:r>
-            <a:r>
-              <a:rPr lang="ko-KR" altLang="en-US" sz="1200">
-                <a:solidFill>
-                  <a:srgbClr val="C3C9D3"/>
-                </a:solidFill>
-                <a:latin typeface="Arial" pitchFamily="34" charset="0"/>
-                <a:ea typeface="Arial" pitchFamily="34" charset="-122"/>
-                <a:cs typeface="Arial" pitchFamily="34" charset="-120"/>
-              </a:rPr>
-              <a:t>분</a:t>
-            </a:r>
-            <a:r>
-              <a:rPr lang="en-US" sz="1200">
-                <a:solidFill>
-                  <a:srgbClr val="C3C9D3"/>
-                </a:solidFill>
-                <a:latin typeface="Arial" pitchFamily="34" charset="0"/>
-                <a:ea typeface="Arial" pitchFamily="34" charset="-122"/>
-                <a:cs typeface="Arial" pitchFamily="34" charset="-120"/>
-              </a:rPr>
-              <a:t> </a:t>
-            </a:r>
-            <a:r>
-              <a:rPr lang="en-US" sz="1200" dirty="0">
-                <a:solidFill>
-                  <a:srgbClr val="C3C9D3"/>
-                </a:solidFill>
-                <a:latin typeface="Arial" pitchFamily="34" charset="0"/>
-                <a:ea typeface="Arial" pitchFamily="34" charset="-122"/>
-                <a:cs typeface="Arial" pitchFamily="34" charset="-120"/>
-              </a:rPr>
-              <a:t>구간, 정답은 직접 셈</a:t>
+              <a:t>사람이 센 정답과 비교는 다음 단계</a:t>
             </a:r>
             <a:endParaRPr lang="en-US" sz="1200" dirty="0"/>
           </a:p>

</xml_diff>